<commit_message>
Fix v2 schematic water loop, add third ceiling cable + relief valve; describe O-ring seals
- v2 schematic: cooling water now runs chiller -> heating head -> generator
  -> chiller; the pyrometer housing hangs from three ceiling cables; a 0.5 psi
  overpressure relief valve hangs from the bottom of the chamber stack at the
  KF40 cross where the bellows connects
- paper.tex: state the series cooling-water order in the heating-path prose,
  and add that every KF40 joint seals on an elastomer O-ring on a centering
  ring (supports the stated operating vacuum, tool-free assembly)
- record the new physical-configuration facts in AGENTS.md

Co-authored-by: Ronnie Guymon <244881888+ronnie-guymon@users.noreply.github.com>
Co-Authored-By: Claude Fable 5 <noreply@anthropic.com>
</commit_message>
<xml_diff>
--- a/docs/induction-furnace-schematic-v2.pptx
+++ b/docs/induction-furnace-schematic-v2.pptx
@@ -4349,7 +4349,7 @@
       </p:grpSpPr>
       <p:sp>
         <p:nvSpPr>
-          <p:cNvPr id="138" name="Rectangle 137"/>
+          <p:cNvPr id="139" name="Rectangle 138"/>
           <p:cNvSpPr/>
           <p:nvPr/>
         </p:nvSpPr>
@@ -6788,6 +6788,41 @@
         </p:nvCxnSpPr>
         <p:spPr>
           <a:xfrm>
+            <a:off x="7843723" y="362102"/>
+            <a:ext cx="257860" cy="4383634"/>
+          </a:xfrm>
+          <a:prstGeom prst="line">
+            <a:avLst/>
+          </a:prstGeom>
+          <a:ln w="38100">
+            <a:solidFill>
+              <a:srgbClr val="000000"/>
+            </a:solidFill>
+          </a:ln>
+        </p:spPr>
+        <p:style>
+          <a:lnRef idx="2">
+            <a:schemeClr val="accent1"/>
+          </a:lnRef>
+          <a:fillRef idx="0">
+            <a:schemeClr val="accent1"/>
+          </a:fillRef>
+          <a:effectRef idx="1">
+            <a:schemeClr val="accent1"/>
+          </a:effectRef>
+          <a:fontRef idx="minor">
+            <a:schemeClr val="tx1"/>
+          </a:fontRef>
+        </p:style>
+      </p:cxnSp>
+      <p:cxnSp>
+        <p:nvCxnSpPr>
+          <p:cNvPr id="136" name="Connector 135"/>
+          <p:cNvCxnSpPr/>
+          <p:nvPr/>
+        </p:nvCxnSpPr>
+        <p:spPr>
+          <a:xfrm>
             <a:off x="1828800" y="6263640"/>
             <a:ext cx="4407408" cy="0"/>
           </a:xfrm>
@@ -6818,7 +6853,7 @@
       </p:cxnSp>
       <p:cxnSp>
         <p:nvCxnSpPr>
-          <p:cNvPr id="136" name="Connector 135"/>
+          <p:cNvPr id="137" name="Connector 136"/>
           <p:cNvCxnSpPr/>
           <p:nvPr/>
         </p:nvCxnSpPr>
@@ -6928,8 +6963,8 @@
         </p:nvSpPr>
         <p:spPr>
           <a:xfrm>
-            <a:off x="1920240" y="6684264"/>
-            <a:ext cx="4663440" cy="1545336"/>
+            <a:off x="1188720" y="6684264"/>
+            <a:ext cx="5394960" cy="265176"/>
           </a:xfrm>
           <a:custGeom>
             <a:avLst/>
@@ -6938,21 +6973,18 @@
             <a:cxnLst/>
             <a:rect l="l" t="t" r="r" b="b"/>
             <a:pathLst>
-              <a:path w="4663440" h="1545336">
+              <a:path w="5394960" h="265176">
                 <a:moveTo>
-                  <a:pt x="4663440" y="0"/>
+                  <a:pt x="5394960" y="0"/>
                 </a:moveTo>
                 <a:lnTo>
-                  <a:pt x="4663440" y="585216"/>
+                  <a:pt x="5394960" y="265176"/>
                 </a:lnTo>
                 <a:lnTo>
-                  <a:pt x="3154680" y="585216"/>
+                  <a:pt x="0" y="265176"/>
                 </a:lnTo>
                 <a:lnTo>
-                  <a:pt x="3154680" y="1545336"/>
-                </a:lnTo>
-                <a:lnTo>
-                  <a:pt x="0" y="1545336"/>
+                  <a:pt x="0" y="128016"/>
                 </a:lnTo>
               </a:path>
             </a:pathLst>
@@ -6990,7 +7022,66 @@
       </p:sp>
       <p:sp>
         <p:nvSpPr>
-          <p:cNvPr id="137" name="TextBox 136"/>
+          <p:cNvPr id="4" name="Freeform 3"/>
+          <p:cNvSpPr/>
+          <p:nvPr/>
+        </p:nvSpPr>
+        <p:spPr>
+          <a:xfrm>
+            <a:off x="822960" y="6812280"/>
+            <a:ext cx="0" cy="960120"/>
+          </a:xfrm>
+          <a:custGeom>
+            <a:avLst/>
+            <a:gdLst/>
+            <a:ahLst/>
+            <a:cxnLst/>
+            <a:rect l="l" t="t" r="r" b="b"/>
+            <a:pathLst>
+              <a:path w="0" h="960120">
+                <a:moveTo>
+                  <a:pt x="0" y="0"/>
+                </a:moveTo>
+                <a:lnTo>
+                  <a:pt x="0" y="960120"/>
+                </a:lnTo>
+              </a:path>
+            </a:pathLst>
+          </a:custGeom>
+          <a:noFill/>
+          <a:ln w="25400">
+            <a:solidFill>
+              <a:srgbClr val="1F6FC4"/>
+            </a:solidFill>
+            <a:tailEnd type="triangle" w="med" len="med"/>
+          </a:ln>
+          <a:effectLst/>
+        </p:spPr>
+        <p:style>
+          <a:lnRef idx="1">
+            <a:schemeClr val="accent1"/>
+          </a:lnRef>
+          <a:fillRef idx="3">
+            <a:schemeClr val="accent1"/>
+          </a:fillRef>
+          <a:effectRef idx="2">
+            <a:schemeClr val="accent1"/>
+          </a:effectRef>
+          <a:fontRef idx="minor">
+            <a:schemeClr val="lt1"/>
+          </a:fontRef>
+        </p:style>
+        <p:txBody>
+          <a:bodyPr rtlCol="0" anchor="ctr"/>
+          <a:lstStyle/>
+          <a:p>
+            <a:pPr algn="ctr"/>
+          </a:p>
+        </p:txBody>
+      </p:sp>
+      <p:sp>
+        <p:nvSpPr>
+          <p:cNvPr id="138" name="TextBox 137"/>
           <p:cNvSpPr txBox="1"/>
           <p:nvPr/>
         </p:nvSpPr>
@@ -7024,7 +7115,7 @@
       </p:sp>
       <p:sp>
         <p:nvSpPr>
-          <p:cNvPr id="139" name="Rectangle 138"/>
+          <p:cNvPr id="140" name="Rectangle 139"/>
           <p:cNvSpPr/>
           <p:nvPr/>
         </p:nvSpPr>
@@ -7068,7 +7159,7 @@
       </p:sp>
       <p:sp>
         <p:nvSpPr>
-          <p:cNvPr id="140" name="TextBox 139"/>
+          <p:cNvPr id="141" name="TextBox 140"/>
           <p:cNvSpPr txBox="1"/>
           <p:nvPr/>
         </p:nvSpPr>
@@ -7098,7 +7189,7 @@
       </p:sp>
       <p:sp>
         <p:nvSpPr>
-          <p:cNvPr id="141" name="Rectangle 140"/>
+          <p:cNvPr id="142" name="Rectangle 141"/>
           <p:cNvSpPr/>
           <p:nvPr/>
         </p:nvSpPr>
@@ -7144,7 +7235,7 @@
       </p:sp>
       <p:sp>
         <p:nvSpPr>
-          <p:cNvPr id="142" name="TextBox 141"/>
+          <p:cNvPr id="143" name="TextBox 142"/>
           <p:cNvSpPr txBox="1"/>
           <p:nvPr/>
         </p:nvSpPr>
@@ -7174,7 +7265,7 @@
       </p:sp>
       <p:cxnSp>
         <p:nvCxnSpPr>
-          <p:cNvPr id="143" name="Connector 142"/>
+          <p:cNvPr id="144" name="Connector 143"/>
           <p:cNvCxnSpPr/>
           <p:nvPr/>
         </p:nvCxnSpPr>
@@ -7210,7 +7301,7 @@
       </p:cxnSp>
       <p:sp>
         <p:nvSpPr>
-          <p:cNvPr id="144" name="TextBox 143"/>
+          <p:cNvPr id="145" name="TextBox 144"/>
           <p:cNvSpPr txBox="1"/>
           <p:nvPr/>
         </p:nvSpPr>
@@ -7240,7 +7331,7 @@
       </p:sp>
       <p:cxnSp>
         <p:nvCxnSpPr>
-          <p:cNvPr id="145" name="Connector 144"/>
+          <p:cNvPr id="146" name="Connector 145"/>
           <p:cNvCxnSpPr/>
           <p:nvPr/>
         </p:nvCxnSpPr>
@@ -7276,7 +7367,7 @@
       </p:cxnSp>
       <p:sp>
         <p:nvSpPr>
-          <p:cNvPr id="146" name="TextBox 145"/>
+          <p:cNvPr id="147" name="TextBox 146"/>
           <p:cNvSpPr txBox="1"/>
           <p:nvPr/>
         </p:nvSpPr>
@@ -7306,7 +7397,7 @@
       </p:sp>
       <p:cxnSp>
         <p:nvCxnSpPr>
-          <p:cNvPr id="147" name="Connector 146"/>
+          <p:cNvPr id="148" name="Connector 147"/>
           <p:cNvCxnSpPr/>
           <p:nvPr/>
         </p:nvCxnSpPr>
@@ -7342,7 +7433,7 @@
       </p:cxnSp>
       <p:sp>
         <p:nvSpPr>
-          <p:cNvPr id="148" name="TextBox 147"/>
+          <p:cNvPr id="149" name="TextBox 148"/>
           <p:cNvSpPr txBox="1"/>
           <p:nvPr/>
         </p:nvSpPr>
@@ -7372,7 +7463,7 @@
       </p:sp>
       <p:cxnSp>
         <p:nvCxnSpPr>
-          <p:cNvPr id="149" name="Connector 148"/>
+          <p:cNvPr id="150" name="Connector 149"/>
           <p:cNvCxnSpPr/>
           <p:nvPr/>
         </p:nvCxnSpPr>
@@ -7408,7 +7499,7 @@
       </p:cxnSp>
       <p:sp>
         <p:nvSpPr>
-          <p:cNvPr id="150" name="TextBox 149"/>
+          <p:cNvPr id="151" name="TextBox 150"/>
           <p:cNvSpPr txBox="1"/>
           <p:nvPr/>
         </p:nvSpPr>
@@ -7438,7 +7529,7 @@
       </p:sp>
       <p:cxnSp>
         <p:nvCxnSpPr>
-          <p:cNvPr id="151" name="Connector 150"/>
+          <p:cNvPr id="152" name="Connector 151"/>
           <p:cNvCxnSpPr/>
           <p:nvPr/>
         </p:nvCxnSpPr>
@@ -7446,6 +7537,153 @@
           <a:xfrm flipH="1">
             <a:off x="7991856" y="7251192"/>
             <a:ext cx="237744" cy="0"/>
+          </a:xfrm>
+          <a:prstGeom prst="line">
+            <a:avLst/>
+          </a:prstGeom>
+          <a:ln w="12700">
+            <a:solidFill>
+              <a:srgbClr val="000000"/>
+            </a:solidFill>
+            <a:tailEnd type="triangle" w="sm" len="sm"/>
+          </a:ln>
+        </p:spPr>
+        <p:style>
+          <a:lnRef idx="2">
+            <a:schemeClr val="accent1"/>
+          </a:lnRef>
+          <a:fillRef idx="0">
+            <a:schemeClr val="accent1"/>
+          </a:fillRef>
+          <a:effectRef idx="1">
+            <a:schemeClr val="accent1"/>
+          </a:effectRef>
+          <a:fontRef idx="minor">
+            <a:schemeClr val="tx1"/>
+          </a:fontRef>
+        </p:style>
+      </p:cxnSp>
+      <p:cxnSp>
+        <p:nvCxnSpPr>
+          <p:cNvPr id="153" name="Connector 152"/>
+          <p:cNvCxnSpPr/>
+          <p:nvPr/>
+        </p:nvCxnSpPr>
+        <p:spPr>
+          <a:xfrm>
+            <a:off x="7964424" y="7589520"/>
+            <a:ext cx="0" cy="228600"/>
+          </a:xfrm>
+          <a:prstGeom prst="line">
+            <a:avLst/>
+          </a:prstGeom>
+          <a:ln w="25400">
+            <a:solidFill>
+              <a:srgbClr val="000000"/>
+            </a:solidFill>
+          </a:ln>
+        </p:spPr>
+        <p:style>
+          <a:lnRef idx="2">
+            <a:schemeClr val="accent1"/>
+          </a:lnRef>
+          <a:fillRef idx="0">
+            <a:schemeClr val="accent1"/>
+          </a:fillRef>
+          <a:effectRef idx="1">
+            <a:schemeClr val="accent1"/>
+          </a:effectRef>
+          <a:fontRef idx="minor">
+            <a:schemeClr val="tx1"/>
+          </a:fontRef>
+        </p:style>
+      </p:cxnSp>
+      <p:sp>
+        <p:nvSpPr>
+          <p:cNvPr id="154" name="Rectangle 153"/>
+          <p:cNvSpPr/>
+          <p:nvPr/>
+        </p:nvSpPr>
+        <p:spPr>
+          <a:xfrm>
+            <a:off x="7891272" y="7818120"/>
+            <a:ext cx="146304" cy="128016"/>
+          </a:xfrm>
+          <a:prstGeom prst="rect">
+            <a:avLst/>
+          </a:prstGeom>
+          <a:solidFill>
+            <a:srgbClr val="FFFFFF"/>
+          </a:solidFill>
+          <a:ln w="15875">
+            <a:solidFill>
+              <a:srgbClr val="000000"/>
+            </a:solidFill>
+          </a:ln>
+          <a:effectLst/>
+        </p:spPr>
+        <p:style>
+          <a:lnRef idx="1">
+            <a:schemeClr val="accent1"/>
+          </a:lnRef>
+          <a:fillRef idx="3">
+            <a:schemeClr val="accent1"/>
+          </a:fillRef>
+          <a:effectRef idx="2">
+            <a:schemeClr val="accent1"/>
+          </a:effectRef>
+          <a:fontRef idx="minor">
+            <a:schemeClr val="lt1"/>
+          </a:fontRef>
+        </p:style>
+        <p:txBody>
+          <a:bodyPr rtlCol="0" anchor="ctr"/>
+          <a:lstStyle/>
+          <a:p>
+            <a:pPr algn="ctr"/>
+          </a:p>
+        </p:txBody>
+      </p:sp>
+      <p:sp>
+        <p:nvSpPr>
+          <p:cNvPr id="155" name="TextBox 154"/>
+          <p:cNvSpPr txBox="1"/>
+          <p:nvPr/>
+        </p:nvSpPr>
+        <p:spPr>
+          <a:xfrm>
+            <a:off x="8247888" y="7763256"/>
+            <a:ext cx="868680" cy="237744"/>
+          </a:xfrm>
+          <a:prstGeom prst="rect">
+            <a:avLst/>
+          </a:prstGeom>
+          <a:noFill/>
+        </p:spPr>
+        <p:txBody>
+          <a:bodyPr wrap="none" lIns="0" rIns="0" tIns="0" bIns="0">
+            <a:spAutoFit/>
+          </a:bodyPr>
+          <a:lstStyle/>
+          <a:p>
+            <a:pPr algn="l"/>
+            <a:r>
+              <a:rPr sz="1000"/>
+              <a:t>Relief Valve</a:t>
+            </a:r>
+          </a:p>
+        </p:txBody>
+      </p:sp>
+      <p:cxnSp>
+        <p:nvCxnSpPr>
+          <p:cNvPr id="156" name="Connector 155"/>
+          <p:cNvCxnSpPr/>
+          <p:nvPr/>
+        </p:nvCxnSpPr>
+        <p:spPr>
+          <a:xfrm flipH="1">
+            <a:off x="8055864" y="7882127"/>
+            <a:ext cx="173736" cy="0"/>
           </a:xfrm>
           <a:prstGeom prst="line">
             <a:avLst/>

</xml_diff>

<commit_message>
Schematic v2: draw two ceiling cables, move generator/chiller in close
Per R. Guymon (PR #3): drop the angled third cable (three exist physically
but two reads better in this side view -- noted in AGENTS.md) and reposition
the induction generator and water chiller next to the heating head/pumping
station, rerouting the RF leads and series cooling-water loop to match.

Co-authored-by: Ronnie Guymon <244881888+ronnie-guymon@users.noreply.github.com>
Co-Authored-By: Claude Fable 5 <noreply@anthropic.com>
</commit_message>
<xml_diff>
--- a/docs/induction-furnace-schematic-v2.pptx
+++ b/docs/induction-furnace-schematic-v2.pptx
@@ -4349,7 +4349,7 @@
       </p:grpSpPr>
       <p:sp>
         <p:nvSpPr>
-          <p:cNvPr id="139" name="Rectangle 138"/>
+          <p:cNvPr id="138" name="Rectangle 137"/>
           <p:cNvSpPr/>
           <p:nvPr/>
         </p:nvSpPr>
@@ -6508,7 +6508,7 @@
         </p:nvSpPr>
         <p:spPr>
           <a:xfrm>
-            <a:off x="548640" y="7772400"/>
+            <a:off x="3566160" y="7772400"/>
             <a:ext cx="1371600" cy="868680"/>
           </a:xfrm>
           <a:prstGeom prst="rect">
@@ -6578,7 +6578,7 @@
         </p:nvSpPr>
         <p:spPr>
           <a:xfrm>
-            <a:off x="548640" y="5989320"/>
+            <a:off x="3657600" y="6080760"/>
             <a:ext cx="1280160" cy="822960"/>
           </a:xfrm>
           <a:prstGeom prst="rect">
@@ -6688,7 +6688,7 @@
         </p:nvSpPr>
         <p:spPr>
           <a:xfrm>
-            <a:off x="1865376" y="5925312"/>
+            <a:off x="4974336" y="5971032"/>
             <a:ext cx="312906" cy="400110"/>
           </a:xfrm>
           <a:prstGeom prst="rect">
@@ -6736,7 +6736,7 @@
         </p:nvSpPr>
         <p:spPr>
           <a:xfrm>
-            <a:off x="1865376" y="6291072"/>
+            <a:off x="4974336" y="6318504"/>
             <a:ext cx="295274" cy="523220"/>
           </a:xfrm>
           <a:prstGeom prst="rect">
@@ -6788,16 +6788,17 @@
         </p:nvCxnSpPr>
         <p:spPr>
           <a:xfrm>
-            <a:off x="7843723" y="362102"/>
-            <a:ext cx="257860" cy="4383634"/>
+            <a:off x="4937760" y="6309360"/>
+            <a:ext cx="1298448" cy="0"/>
           </a:xfrm>
           <a:prstGeom prst="line">
             <a:avLst/>
           </a:prstGeom>
-          <a:ln w="38100">
+          <a:ln w="25400">
             <a:solidFill>
               <a:srgbClr val="000000"/>
             </a:solidFill>
+            <a:prstDash val="sysDot"/>
           </a:ln>
         </p:spPr>
         <p:style>
@@ -6823,8 +6824,8 @@
         </p:nvCxnSpPr>
         <p:spPr>
           <a:xfrm>
-            <a:off x="1828800" y="6263640"/>
-            <a:ext cx="4407408" cy="0"/>
+            <a:off x="4937760" y="6565392"/>
+            <a:ext cx="1298448" cy="0"/>
           </a:xfrm>
           <a:prstGeom prst="line">
             <a:avLst/>
@@ -6851,42 +6852,6 @@
           </a:fontRef>
         </p:style>
       </p:cxnSp>
-      <p:cxnSp>
-        <p:nvCxnSpPr>
-          <p:cNvPr id="137" name="Connector 136"/>
-          <p:cNvCxnSpPr/>
-          <p:nvPr/>
-        </p:nvCxnSpPr>
-        <p:spPr>
-          <a:xfrm>
-            <a:off x="1828800" y="6537960"/>
-            <a:ext cx="4407408" cy="0"/>
-          </a:xfrm>
-          <a:prstGeom prst="line">
-            <a:avLst/>
-          </a:prstGeom>
-          <a:ln w="25400">
-            <a:solidFill>
-              <a:srgbClr val="000000"/>
-            </a:solidFill>
-            <a:prstDash val="sysDot"/>
-          </a:ln>
-        </p:spPr>
-        <p:style>
-          <a:lnRef idx="2">
-            <a:schemeClr val="accent1"/>
-          </a:lnRef>
-          <a:fillRef idx="0">
-            <a:schemeClr val="accent1"/>
-          </a:fillRef>
-          <a:effectRef idx="1">
-            <a:schemeClr val="accent1"/>
-          </a:effectRef>
-          <a:fontRef idx="minor">
-            <a:schemeClr val="tx1"/>
-          </a:fontRef>
-        </p:style>
-      </p:cxnSp>
       <p:sp>
         <p:nvSpPr>
           <p:cNvPr id="2" name="Freeform 1"/>
@@ -6895,8 +6860,8 @@
         </p:nvSpPr>
         <p:spPr>
           <a:xfrm>
-            <a:off x="1920240" y="6684264"/>
-            <a:ext cx="4434840" cy="1271015"/>
+            <a:off x="4937760" y="6684264"/>
+            <a:ext cx="1417320" cy="1271015"/>
           </a:xfrm>
           <a:custGeom>
             <a:avLst/>
@@ -6905,21 +6870,21 @@
             <a:cxnLst/>
             <a:rect l="l" t="t" r="r" b="b"/>
             <a:pathLst>
-              <a:path w="4434840" h="1271015">
+              <a:path w="1417320" h="1271015">
                 <a:moveTo>
                   <a:pt x="0" y="1271015"/>
                 </a:moveTo>
                 <a:lnTo>
-                  <a:pt x="2971800" y="1271015"/>
+                  <a:pt x="155448" y="1271015"/>
                 </a:lnTo>
                 <a:lnTo>
-                  <a:pt x="2971800" y="402336"/>
+                  <a:pt x="155448" y="402336"/>
                 </a:lnTo>
                 <a:lnTo>
-                  <a:pt x="4434840" y="402336"/>
+                  <a:pt x="1417320" y="402336"/>
                 </a:lnTo>
                 <a:lnTo>
-                  <a:pt x="4434840" y="0"/>
+                  <a:pt x="1417320" y="0"/>
                 </a:lnTo>
               </a:path>
             </a:pathLst>
@@ -6963,8 +6928,8 @@
         </p:nvSpPr>
         <p:spPr>
           <a:xfrm>
-            <a:off x="1188720" y="6684264"/>
-            <a:ext cx="5394960" cy="265176"/>
+            <a:off x="4480560" y="6684264"/>
+            <a:ext cx="2103120" cy="310896"/>
           </a:xfrm>
           <a:custGeom>
             <a:avLst/>
@@ -6973,18 +6938,18 @@
             <a:cxnLst/>
             <a:rect l="l" t="t" r="r" b="b"/>
             <a:pathLst>
-              <a:path w="5394960" h="265176">
+              <a:path w="2103120" h="310896">
                 <a:moveTo>
-                  <a:pt x="5394960" y="0"/>
+                  <a:pt x="2103120" y="0"/>
                 </a:moveTo>
                 <a:lnTo>
-                  <a:pt x="5394960" y="265176"/>
+                  <a:pt x="2103120" y="310896"/>
                 </a:lnTo>
                 <a:lnTo>
-                  <a:pt x="0" y="265176"/>
+                  <a:pt x="0" y="310896"/>
                 </a:lnTo>
                 <a:lnTo>
-                  <a:pt x="0" y="128016"/>
+                  <a:pt x="0" y="219456"/>
                 </a:lnTo>
               </a:path>
             </a:pathLst>
@@ -7028,8 +6993,8 @@
         </p:nvSpPr>
         <p:spPr>
           <a:xfrm>
-            <a:off x="822960" y="6812280"/>
-            <a:ext cx="0" cy="960120"/>
+            <a:off x="3931920" y="6903720"/>
+            <a:ext cx="0" cy="868680"/>
           </a:xfrm>
           <a:custGeom>
             <a:avLst/>
@@ -7038,12 +7003,12 @@
             <a:cxnLst/>
             <a:rect l="l" t="t" r="r" b="b"/>
             <a:pathLst>
-              <a:path w="0" h="960120">
+              <a:path w="0" h="868680">
                 <a:moveTo>
                   <a:pt x="0" y="0"/>
                 </a:moveTo>
                 <a:lnTo>
-                  <a:pt x="0" y="960120"/>
+                  <a:pt x="0" y="868680"/>
                 </a:lnTo>
               </a:path>
             </a:pathLst>
@@ -7081,13 +7046,13 @@
       </p:sp>
       <p:sp>
         <p:nvSpPr>
-          <p:cNvPr id="138" name="TextBox 137"/>
+          <p:cNvPr id="137" name="TextBox 136"/>
           <p:cNvSpPr txBox="1"/>
           <p:nvPr/>
         </p:nvSpPr>
         <p:spPr>
           <a:xfrm>
-            <a:off x="2148840" y="7662672"/>
+            <a:off x="4069080" y="7296912"/>
             <a:ext cx="1051560" cy="237744"/>
           </a:xfrm>
           <a:prstGeom prst="rect">
@@ -7115,7 +7080,7 @@
       </p:sp>
       <p:sp>
         <p:nvSpPr>
-          <p:cNvPr id="140" name="Rectangle 139"/>
+          <p:cNvPr id="139" name="Rectangle 138"/>
           <p:cNvSpPr/>
           <p:nvPr/>
         </p:nvSpPr>
@@ -7159,7 +7124,7 @@
       </p:sp>
       <p:sp>
         <p:nvSpPr>
-          <p:cNvPr id="141" name="TextBox 140"/>
+          <p:cNvPr id="140" name="TextBox 139"/>
           <p:cNvSpPr txBox="1"/>
           <p:nvPr/>
         </p:nvSpPr>
@@ -7189,7 +7154,7 @@
       </p:sp>
       <p:sp>
         <p:nvSpPr>
-          <p:cNvPr id="142" name="Rectangle 141"/>
+          <p:cNvPr id="141" name="Rectangle 140"/>
           <p:cNvSpPr/>
           <p:nvPr/>
         </p:nvSpPr>
@@ -7235,13 +7200,13 @@
       </p:sp>
       <p:sp>
         <p:nvSpPr>
-          <p:cNvPr id="143" name="TextBox 142"/>
+          <p:cNvPr id="142" name="TextBox 141"/>
           <p:cNvSpPr txBox="1"/>
           <p:nvPr/>
         </p:nvSpPr>
         <p:spPr>
           <a:xfrm>
-            <a:off x="4041648" y="5788152"/>
+            <a:off x="2898648" y="5788152"/>
             <a:ext cx="1993392" cy="237744"/>
           </a:xfrm>
           <a:prstGeom prst="rect">
@@ -7265,14 +7230,14 @@
       </p:sp>
       <p:cxnSp>
         <p:nvCxnSpPr>
-          <p:cNvPr id="144" name="Connector 143"/>
+          <p:cNvPr id="143" name="Connector 142"/>
           <p:cNvCxnSpPr/>
           <p:nvPr/>
         </p:nvCxnSpPr>
         <p:spPr>
           <a:xfrm>
-            <a:off x="6080760" y="5907024"/>
-            <a:ext cx="1600200" cy="82296"/>
+            <a:off x="4956048" y="5907024"/>
+            <a:ext cx="2724912" cy="82296"/>
           </a:xfrm>
           <a:prstGeom prst="line">
             <a:avLst/>
@@ -7301,7 +7266,7 @@
       </p:cxnSp>
       <p:sp>
         <p:nvSpPr>
-          <p:cNvPr id="145" name="TextBox 144"/>
+          <p:cNvPr id="144" name="TextBox 143"/>
           <p:cNvSpPr txBox="1"/>
           <p:nvPr/>
         </p:nvSpPr>
@@ -7331,7 +7296,7 @@
       </p:sp>
       <p:cxnSp>
         <p:nvCxnSpPr>
-          <p:cNvPr id="146" name="Connector 145"/>
+          <p:cNvPr id="145" name="Connector 144"/>
           <p:cNvCxnSpPr/>
           <p:nvPr/>
         </p:nvCxnSpPr>
@@ -7367,7 +7332,7 @@
       </p:cxnSp>
       <p:sp>
         <p:nvSpPr>
-          <p:cNvPr id="147" name="TextBox 146"/>
+          <p:cNvPr id="146" name="TextBox 145"/>
           <p:cNvSpPr txBox="1"/>
           <p:nvPr/>
         </p:nvSpPr>
@@ -7397,7 +7362,7 @@
       </p:sp>
       <p:cxnSp>
         <p:nvCxnSpPr>
-          <p:cNvPr id="148" name="Connector 147"/>
+          <p:cNvPr id="147" name="Connector 146"/>
           <p:cNvCxnSpPr/>
           <p:nvPr/>
         </p:nvCxnSpPr>
@@ -7433,7 +7398,7 @@
       </p:cxnSp>
       <p:sp>
         <p:nvSpPr>
-          <p:cNvPr id="149" name="TextBox 148"/>
+          <p:cNvPr id="148" name="TextBox 147"/>
           <p:cNvSpPr txBox="1"/>
           <p:nvPr/>
         </p:nvSpPr>
@@ -7463,7 +7428,7 @@
       </p:sp>
       <p:cxnSp>
         <p:nvCxnSpPr>
-          <p:cNvPr id="150" name="Connector 149"/>
+          <p:cNvPr id="149" name="Connector 148"/>
           <p:cNvCxnSpPr/>
           <p:nvPr/>
         </p:nvCxnSpPr>
@@ -7499,7 +7464,7 @@
       </p:cxnSp>
       <p:sp>
         <p:nvSpPr>
-          <p:cNvPr id="151" name="TextBox 150"/>
+          <p:cNvPr id="150" name="TextBox 149"/>
           <p:cNvSpPr txBox="1"/>
           <p:nvPr/>
         </p:nvSpPr>
@@ -7529,7 +7494,7 @@
       </p:sp>
       <p:cxnSp>
         <p:nvCxnSpPr>
-          <p:cNvPr id="152" name="Connector 151"/>
+          <p:cNvPr id="151" name="Connector 150"/>
           <p:cNvCxnSpPr/>
           <p:nvPr/>
         </p:nvCxnSpPr>
@@ -7565,7 +7530,7 @@
       </p:cxnSp>
       <p:cxnSp>
         <p:nvCxnSpPr>
-          <p:cNvPr id="153" name="Connector 152"/>
+          <p:cNvPr id="152" name="Connector 151"/>
           <p:cNvCxnSpPr/>
           <p:nvPr/>
         </p:nvCxnSpPr>
@@ -7600,7 +7565,7 @@
       </p:cxnSp>
       <p:sp>
         <p:nvSpPr>
-          <p:cNvPr id="154" name="Rectangle 153"/>
+          <p:cNvPr id="153" name="Rectangle 152"/>
           <p:cNvSpPr/>
           <p:nvPr/>
         </p:nvSpPr>
@@ -7646,7 +7611,7 @@
       </p:sp>
       <p:sp>
         <p:nvSpPr>
-          <p:cNvPr id="155" name="TextBox 154"/>
+          <p:cNvPr id="154" name="TextBox 153"/>
           <p:cNvSpPr txBox="1"/>
           <p:nvPr/>
         </p:nvSpPr>
@@ -7676,7 +7641,7 @@
       </p:sp>
       <p:cxnSp>
         <p:nvCxnSpPr>
-          <p:cNvPr id="156" name="Connector 155"/>
+          <p:cNvPr id="155" name="Connector 154"/>
           <p:cNvCxnSpPr/>
           <p:nvPr/>
         </p:nvCxnSpPr>

</xml_diff>

<commit_message>
Coolant is ethylene glycol, not water; note P-Trap fact for later
Relabel the v2 schematic loop "Ethylene Glycol Coolant" and the chiller
"Recirculating Chiller"; the manuscript now says "ethylene glycol coolant"
and "liquid-cooled". Record the P-Trap (turbopump debris protection) in
AGENTS.md only, per "don't include yet".

Co-authored-by: Ronnie Guymon <244881888+ronnie-guymon@users.noreply.github.com>

Co-Authored-By: Claude Fable 5 <noreply@anthropic.com>
</commit_message>
<xml_diff>
--- a/docs/induction-furnace-schematic-v2.pptx
+++ b/docs/induction-furnace-schematic-v2.pptx
@@ -6559,7 +6559,7 @@
                   <a:srgbClr val="000000"/>
                 </a:solidFill>
               </a:rPr>
-              <a:t>Water Chiller</a:t>
+              <a:t>Chiller</a:t>
             </a:r>
           </a:p>
         </p:txBody>
@@ -7052,8 +7052,8 @@
         </p:nvSpPr>
         <p:spPr>
           <a:xfrm>
-            <a:off x="4041648" y="7296912"/>
-            <a:ext cx="1005840" cy="237744"/>
+            <a:off x="2194560" y="7296912"/>
+            <a:ext cx="1691640" cy="237744"/>
           </a:xfrm>
           <a:prstGeom prst="rect">
             <a:avLst/>
@@ -7066,14 +7066,14 @@
           </a:bodyPr>
           <a:lstStyle/>
           <a:p>
-            <a:pPr algn="l"/>
+            <a:pPr algn="r"/>
             <a:r>
               <a:rPr sz="1000">
                 <a:solidFill>
                   <a:srgbClr val="1F6FC4"/>
                 </a:solidFill>
               </a:rPr>
-              <a:t>Cooling Water</a:t>
+              <a:t>Ethylene Glycol Coolant</a:t>
             </a:r>
           </a:p>
         </p:txBody>

</xml_diff>